<commit_message>
Update Presentación de Avances.pptx
</commit_message>
<xml_diff>
--- a/Presentación de Avances.pptx
+++ b/Presentación de Avances.pptx
@@ -109,6 +109,11 @@
       </a:defRPr>
     </a:lvl9pPr>
   </p:defaultTextStyle>
+  <p:extLst>
+    <p:ext uri="{EFAFB233-063F-42B5-8137-9DF3F51BA10A}">
+      <p15:sldGuideLst xmlns:p15="http://schemas.microsoft.com/office/powerpoint/2012/main"/>
+    </p:ext>
+  </p:extLst>
 </p:presentation>
 </file>
 
@@ -261,7 +266,7 @@
           <a:p>
             <a:fld id="{BD76D514-7364-4261-BB5A-3242DE0784F6}" type="datetimeFigureOut">
               <a:rPr lang="es-CL" smtClean="0"/>
-              <a:t>08-06-2026</a:t>
+              <a:t>09-06-2026</a:t>
             </a:fld>
             <a:endParaRPr lang="es-CL"/>
           </a:p>
@@ -461,7 +466,7 @@
           <a:p>
             <a:fld id="{BD76D514-7364-4261-BB5A-3242DE0784F6}" type="datetimeFigureOut">
               <a:rPr lang="es-CL" smtClean="0"/>
-              <a:t>08-06-2026</a:t>
+              <a:t>09-06-2026</a:t>
             </a:fld>
             <a:endParaRPr lang="es-CL"/>
           </a:p>
@@ -671,7 +676,7 @@
           <a:p>
             <a:fld id="{BD76D514-7364-4261-BB5A-3242DE0784F6}" type="datetimeFigureOut">
               <a:rPr lang="es-CL" smtClean="0"/>
-              <a:t>08-06-2026</a:t>
+              <a:t>09-06-2026</a:t>
             </a:fld>
             <a:endParaRPr lang="es-CL"/>
           </a:p>
@@ -871,7 +876,7 @@
           <a:p>
             <a:fld id="{BD76D514-7364-4261-BB5A-3242DE0784F6}" type="datetimeFigureOut">
               <a:rPr lang="es-CL" smtClean="0"/>
-              <a:t>08-06-2026</a:t>
+              <a:t>09-06-2026</a:t>
             </a:fld>
             <a:endParaRPr lang="es-CL"/>
           </a:p>
@@ -1147,7 +1152,7 @@
           <a:p>
             <a:fld id="{BD76D514-7364-4261-BB5A-3242DE0784F6}" type="datetimeFigureOut">
               <a:rPr lang="es-CL" smtClean="0"/>
-              <a:t>08-06-2026</a:t>
+              <a:t>09-06-2026</a:t>
             </a:fld>
             <a:endParaRPr lang="es-CL"/>
           </a:p>
@@ -1415,7 +1420,7 @@
           <a:p>
             <a:fld id="{BD76D514-7364-4261-BB5A-3242DE0784F6}" type="datetimeFigureOut">
               <a:rPr lang="es-CL" smtClean="0"/>
-              <a:t>08-06-2026</a:t>
+              <a:t>09-06-2026</a:t>
             </a:fld>
             <a:endParaRPr lang="es-CL"/>
           </a:p>
@@ -1830,7 +1835,7 @@
           <a:p>
             <a:fld id="{BD76D514-7364-4261-BB5A-3242DE0784F6}" type="datetimeFigureOut">
               <a:rPr lang="es-CL" smtClean="0"/>
-              <a:t>08-06-2026</a:t>
+              <a:t>09-06-2026</a:t>
             </a:fld>
             <a:endParaRPr lang="es-CL"/>
           </a:p>
@@ -1972,7 +1977,7 @@
           <a:p>
             <a:fld id="{BD76D514-7364-4261-BB5A-3242DE0784F6}" type="datetimeFigureOut">
               <a:rPr lang="es-CL" smtClean="0"/>
-              <a:t>08-06-2026</a:t>
+              <a:t>09-06-2026</a:t>
             </a:fld>
             <a:endParaRPr lang="es-CL"/>
           </a:p>
@@ -2085,7 +2090,7 @@
           <a:p>
             <a:fld id="{BD76D514-7364-4261-BB5A-3242DE0784F6}" type="datetimeFigureOut">
               <a:rPr lang="es-CL" smtClean="0"/>
-              <a:t>08-06-2026</a:t>
+              <a:t>09-06-2026</a:t>
             </a:fld>
             <a:endParaRPr lang="es-CL"/>
           </a:p>
@@ -2398,7 +2403,7 @@
           <a:p>
             <a:fld id="{BD76D514-7364-4261-BB5A-3242DE0784F6}" type="datetimeFigureOut">
               <a:rPr lang="es-CL" smtClean="0"/>
-              <a:t>08-06-2026</a:t>
+              <a:t>09-06-2026</a:t>
             </a:fld>
             <a:endParaRPr lang="es-CL"/>
           </a:p>
@@ -2687,7 +2692,7 @@
           <a:p>
             <a:fld id="{BD76D514-7364-4261-BB5A-3242DE0784F6}" type="datetimeFigureOut">
               <a:rPr lang="es-CL" smtClean="0"/>
-              <a:t>08-06-2026</a:t>
+              <a:t>09-06-2026</a:t>
             </a:fld>
             <a:endParaRPr lang="es-CL"/>
           </a:p>
@@ -2930,7 +2935,7 @@
           <a:p>
             <a:fld id="{BD76D514-7364-4261-BB5A-3242DE0784F6}" type="datetimeFigureOut">
               <a:rPr lang="es-CL" smtClean="0"/>
-              <a:t>08-06-2026</a:t>
+              <a:t>09-06-2026</a:t>
             </a:fld>
             <a:endParaRPr lang="es-CL"/>
           </a:p>
@@ -6046,31 +6051,29 @@
       </p:sp>
       <p:pic>
         <p:nvPicPr>
-          <p:cNvPr id="4" name="Marcador de contenido 3">
-            <a:extLst>
-              <a:ext uri="{FF2B5EF4-FFF2-40B4-BE49-F238E27FC236}">
-                <a16:creationId xmlns:a16="http://schemas.microsoft.com/office/drawing/2014/main" id="{872FBB46-FBF1-BEA8-0D7E-32533584E282}"/>
+          <p:cNvPr id="7" name="Imagen 6">
+            <a:extLst>
+              <a:ext uri="{FF2B5EF4-FFF2-40B4-BE49-F238E27FC236}">
+                <a16:creationId xmlns:a16="http://schemas.microsoft.com/office/drawing/2014/main" id="{5E077038-8485-7CC7-7F87-C69F3B24C07D}"/>
               </a:ext>
             </a:extLst>
           </p:cNvPr>
           <p:cNvPicPr>
-            <a:picLocks noGrp="1" noChangeAspect="1"/>
+            <a:picLocks noChangeAspect="1"/>
           </p:cNvPicPr>
-          <p:nvPr>
-            <p:ph idx="1"/>
-          </p:nvPr>
+          <p:nvPr/>
         </p:nvPicPr>
         <p:blipFill>
           <a:blip r:embed="rId2"/>
-          <a:srcRect l="4495" t="20104" r="10789" b="12932"/>
+          <a:srcRect l="4073" t="21873" r="40" b="16162"/>
           <a:stretch>
             <a:fillRect/>
           </a:stretch>
         </p:blipFill>
         <p:spPr>
           <a:xfrm>
-            <a:off x="495899" y="1586615"/>
-            <a:ext cx="11200202" cy="4979943"/>
+            <a:off x="250722" y="1877526"/>
+            <a:ext cx="11690555" cy="4247536"/>
           </a:xfrm>
           <a:prstGeom prst="rect">
             <a:avLst/>

</xml_diff>